<commit_message>
Summer Thursday sessions: 7-week auto-rotating curriculum, updated program info (REC406/407)
Co-Authored-By: Claude Fable 5 <noreply@anthropic.com>
</commit_message>
<xml_diff>
--- a/public/plans/2026-04-27.pptx
+++ b/public/plans/2026-04-27.pptx
@@ -8972,7 +8972,7 @@
                 </a:solidFill>
                 <a:latin typeface="Calibri"/>
               </a:rPr>
-              <a:t>Ages 3–5  ·  45 minute session</a:t>
+              <a:t>Ages 3–5 · 45 minute session</a:t>
             </a:r>
           </a:p>
         </p:txBody>
@@ -9189,7 +9189,7 @@
                 </a:solidFill>
                 <a:latin typeface="Calibri"/>
               </a:rPr>
-              <a:t>COACH PLAYBOOK · PRE-K &amp; K</a:t>
+              <a:t>COACH PLAYBOOK · PRE-K &amp; KINDERGARTEN</a:t>
             </a:r>
           </a:p>
         </p:txBody>
@@ -12131,7 +12131,7 @@
                 </a:solidFill>
                 <a:latin typeface="Calibri"/>
               </a:rPr>
-              <a:t>qmtk Soccer · Coach Playbook · Pre-K &amp; K</a:t>
+              <a:t>qmtk Soccer · Coach Playbook · Pre-K &amp; Kindergarten</a:t>
             </a:r>
           </a:p>
         </p:txBody>
@@ -12348,7 +12348,7 @@
                 </a:solidFill>
                 <a:latin typeface="Calibri"/>
               </a:rPr>
-              <a:t>COACH PLAYBOOK · PRE-K &amp; K</a:t>
+              <a:t>COACH PLAYBOOK · PRE-K &amp; KINDERGARTEN</a:t>
             </a:r>
           </a:p>
         </p:txBody>
@@ -15052,7 +15052,7 @@
                 </a:solidFill>
                 <a:latin typeface="Calibri"/>
               </a:rPr>
-              <a:t>qmtk Soccer · Coach Playbook · Pre-K &amp; K</a:t>
+              <a:t>qmtk Soccer · Coach Playbook · Pre-K &amp; Kindergarten</a:t>
             </a:r>
           </a:p>
         </p:txBody>
@@ -15269,7 +15269,7 @@
                 </a:solidFill>
                 <a:latin typeface="Calibri"/>
               </a:rPr>
-              <a:t>COACH PLAYBOOK · PRE-K &amp; K</a:t>
+              <a:t>COACH PLAYBOOK · PRE-K &amp; KINDERGARTEN</a:t>
             </a:r>
           </a:p>
         </p:txBody>
@@ -18124,7 +18124,7 @@
                 </a:solidFill>
                 <a:latin typeface="Calibri"/>
               </a:rPr>
-              <a:t>qmtk Soccer · Coach Playbook · Pre-K &amp; K</a:t>
+              <a:t>qmtk Soccer · Coach Playbook · Pre-K &amp; Kindergarten</a:t>
             </a:r>
           </a:p>
         </p:txBody>
@@ -18341,7 +18341,7 @@
                 </a:solidFill>
                 <a:latin typeface="Calibri"/>
               </a:rPr>
-              <a:t>COACH PLAYBOOK · PRE-K &amp; K</a:t>
+              <a:t>COACH PLAYBOOK · PRE-K &amp; KINDERGARTEN</a:t>
             </a:r>
           </a:p>
         </p:txBody>
@@ -20736,7 +20736,7 @@
                 </a:solidFill>
                 <a:latin typeface="Calibri"/>
               </a:rPr>
-              <a:t>qmtk Soccer · Coach Playbook · Pre-K &amp; K</a:t>
+              <a:t>qmtk Soccer · Coach Playbook · Pre-K &amp; Kindergarten</a:t>
             </a:r>
           </a:p>
         </p:txBody>
@@ -21066,7 +21066,7 @@
                 </a:solidFill>
                 <a:latin typeface="Calibri"/>
               </a:rPr>
-              <a:t>Ages 6–11  ·  60 minute session</a:t>
+              <a:t>Ages 6–11 · 60 minute session</a:t>
             </a:r>
           </a:p>
         </p:txBody>

</xml_diff>